<commit_message>
add: new powerpoint slide
</commit_message>
<xml_diff>
--- a/CAS_Projekt_Erweiterungen.pptx
+++ b/CAS_Projekt_Erweiterungen.pptx
@@ -9,7 +9,8 @@
     <p:sldId id="257" r:id="rId3"/>
     <p:sldId id="258" r:id="rId4"/>
     <p:sldId id="259" r:id="rId5"/>
-    <p:sldId id="260" r:id="rId6"/>
+    <p:sldId id="261" r:id="rId6"/>
+    <p:sldId id="260" r:id="rId7"/>
   </p:sldIdLst>
   <p:sldSz cx="12192000" cy="6858000"/>
   <p:notesSz cx="6858000" cy="9144000"/>
@@ -140,7 +141,7 @@
   <pc:docChgLst>
     <pc:chgData name="Etzlinger Niklas - s2510455021" userId="6ea425b0-5910-42fe-91d8-016da0ddcc9e" providerId="ADAL" clId="{108ED526-C972-5892-8A1A-B3E7D0F38F9C}"/>
     <pc:docChg chg="undo custSel addSld modSld">
-      <pc:chgData name="Etzlinger Niklas - s2510455021" userId="6ea425b0-5910-42fe-91d8-016da0ddcc9e" providerId="ADAL" clId="{108ED526-C972-5892-8A1A-B3E7D0F38F9C}" dt="2026-07-20T09:41:54.831" v="113" actId="1076"/>
+      <pc:chgData name="Etzlinger Niklas - s2510455021" userId="6ea425b0-5910-42fe-91d8-016da0ddcc9e" providerId="ADAL" clId="{108ED526-C972-5892-8A1A-B3E7D0F38F9C}" dt="2026-07-20T12:38:16.129" v="124" actId="2710"/>
       <pc:docMkLst>
         <pc:docMk/>
       </pc:docMkLst>
@@ -241,6 +242,85 @@
             <pc:docMk/>
             <pc:sldMk cId="2487526771" sldId="260"/>
             <ac:spMk id="7" creationId="{1B4D0E7F-5D19-75A0-6BFB-8B9DD861B59D}"/>
+          </ac:spMkLst>
+        </pc:spChg>
+      </pc:sldChg>
+      <pc:sldChg chg="delSp modSp mod">
+        <pc:chgData name="Etzlinger Niklas - s2510455021" userId="6ea425b0-5910-42fe-91d8-016da0ddcc9e" providerId="ADAL" clId="{108ED526-C972-5892-8A1A-B3E7D0F38F9C}" dt="2026-07-20T12:38:16.129" v="124" actId="2710"/>
+        <pc:sldMkLst>
+          <pc:docMk/>
+          <pc:sldMk cId="0" sldId="261"/>
+        </pc:sldMkLst>
+        <pc:spChg chg="mod">
+          <ac:chgData name="Etzlinger Niklas - s2510455021" userId="6ea425b0-5910-42fe-91d8-016da0ddcc9e" providerId="ADAL" clId="{108ED526-C972-5892-8A1A-B3E7D0F38F9C}" dt="2026-07-20T12:38:16.129" v="124" actId="2710"/>
+          <ac:spMkLst>
+            <pc:docMk/>
+            <pc:sldMk cId="0" sldId="261"/>
+            <ac:spMk id="5" creationId="{00000000-0000-0000-0000-000000000000}"/>
+          </ac:spMkLst>
+        </pc:spChg>
+        <pc:spChg chg="del">
+          <ac:chgData name="Etzlinger Niklas - s2510455021" userId="6ea425b0-5910-42fe-91d8-016da0ddcc9e" providerId="ADAL" clId="{108ED526-C972-5892-8A1A-B3E7D0F38F9C}" dt="2026-07-20T12:38:04.230" v="119" actId="478"/>
+          <ac:spMkLst>
+            <pc:docMk/>
+            <pc:sldMk cId="0" sldId="261"/>
+            <ac:spMk id="6" creationId="{00000000-0000-0000-0000-000000000000}"/>
+          </ac:spMkLst>
+        </pc:spChg>
+        <pc:spChg chg="del">
+          <ac:chgData name="Etzlinger Niklas - s2510455021" userId="6ea425b0-5910-42fe-91d8-016da0ddcc9e" providerId="ADAL" clId="{108ED526-C972-5892-8A1A-B3E7D0F38F9C}" dt="2026-07-20T12:38:03.395" v="118" actId="478"/>
+          <ac:spMkLst>
+            <pc:docMk/>
+            <pc:sldMk cId="0" sldId="261"/>
+            <ac:spMk id="7" creationId="{00000000-0000-0000-0000-000000000000}"/>
+          </ac:spMkLst>
+        </pc:spChg>
+        <pc:spChg chg="del">
+          <ac:chgData name="Etzlinger Niklas - s2510455021" userId="6ea425b0-5910-42fe-91d8-016da0ddcc9e" providerId="ADAL" clId="{108ED526-C972-5892-8A1A-B3E7D0F38F9C}" dt="2026-07-20T12:38:04.821" v="120" actId="478"/>
+          <ac:spMkLst>
+            <pc:docMk/>
+            <pc:sldMk cId="0" sldId="261"/>
+            <ac:spMk id="8" creationId="{00000000-0000-0000-0000-000000000000}"/>
+          </ac:spMkLst>
+        </pc:spChg>
+        <pc:spChg chg="del mod">
+          <ac:chgData name="Etzlinger Niklas - s2510455021" userId="6ea425b0-5910-42fe-91d8-016da0ddcc9e" providerId="ADAL" clId="{108ED526-C972-5892-8A1A-B3E7D0F38F9C}" dt="2026-07-20T12:38:01.565" v="117" actId="478"/>
+          <ac:spMkLst>
+            <pc:docMk/>
+            <pc:sldMk cId="0" sldId="261"/>
+            <ac:spMk id="9" creationId="{00000000-0000-0000-0000-000000000000}"/>
+          </ac:spMkLst>
+        </pc:spChg>
+        <pc:spChg chg="del">
+          <ac:chgData name="Etzlinger Niklas - s2510455021" userId="6ea425b0-5910-42fe-91d8-016da0ddcc9e" providerId="ADAL" clId="{108ED526-C972-5892-8A1A-B3E7D0F38F9C}" dt="2026-07-20T12:38:06.953" v="121" actId="478"/>
+          <ac:spMkLst>
+            <pc:docMk/>
+            <pc:sldMk cId="0" sldId="261"/>
+            <ac:spMk id="10" creationId="{00000000-0000-0000-0000-000000000000}"/>
+          </ac:spMkLst>
+        </pc:spChg>
+        <pc:spChg chg="del">
+          <ac:chgData name="Etzlinger Niklas - s2510455021" userId="6ea425b0-5910-42fe-91d8-016da0ddcc9e" providerId="ADAL" clId="{108ED526-C972-5892-8A1A-B3E7D0F38F9C}" dt="2026-07-20T12:37:59.285" v="115" actId="478"/>
+          <ac:spMkLst>
+            <pc:docMk/>
+            <pc:sldMk cId="0" sldId="261"/>
+            <ac:spMk id="11" creationId="{00000000-0000-0000-0000-000000000000}"/>
+          </ac:spMkLst>
+        </pc:spChg>
+        <pc:spChg chg="del">
+          <ac:chgData name="Etzlinger Niklas - s2510455021" userId="6ea425b0-5910-42fe-91d8-016da0ddcc9e" providerId="ADAL" clId="{108ED526-C972-5892-8A1A-B3E7D0F38F9C}" dt="2026-07-20T12:38:07.638" v="122" actId="478"/>
+          <ac:spMkLst>
+            <pc:docMk/>
+            <pc:sldMk cId="0" sldId="261"/>
+            <ac:spMk id="12" creationId="{00000000-0000-0000-0000-000000000000}"/>
+          </ac:spMkLst>
+        </pc:spChg>
+        <pc:spChg chg="del">
+          <ac:chgData name="Etzlinger Niklas - s2510455021" userId="6ea425b0-5910-42fe-91d8-016da0ddcc9e" providerId="ADAL" clId="{108ED526-C972-5892-8A1A-B3E7D0F38F9C}" dt="2026-07-20T12:37:58.087" v="114" actId="478"/>
+          <ac:spMkLst>
+            <pc:docMk/>
+            <pc:sldMk cId="0" sldId="261"/>
+            <ac:spMk id="13" creationId="{00000000-0000-0000-0000-000000000000}"/>
           </ac:spMkLst>
         </pc:spChg>
       </pc:sldChg>
@@ -6778,6 +6858,1003 @@
 </file>
 
 <file path=ppt/slides/slide5.xml><?xml version="1.0" encoding="utf-8"?>
+<p:sld xmlns:a="http://schemas.openxmlformats.org/drawingml/2006/main" xmlns:r="http://schemas.openxmlformats.org/officeDocument/2006/relationships" xmlns:p="http://schemas.openxmlformats.org/presentationml/2006/main">
+  <p:cSld>
+    <p:spTree>
+      <p:nvGrpSpPr>
+        <p:cNvPr id="1" name=""/>
+        <p:cNvGrpSpPr/>
+        <p:nvPr/>
+      </p:nvGrpSpPr>
+      <p:grpSpPr>
+        <a:xfrm>
+          <a:off x="0" y="0"/>
+          <a:ext cx="0" cy="0"/>
+          <a:chOff x="0" y="0"/>
+          <a:chExt cx="0" cy="0"/>
+        </a:xfrm>
+      </p:grpSpPr>
+      <p:sp>
+        <p:nvSpPr>
+          <p:cNvPr id="2" name="TextBox 1"/>
+          <p:cNvSpPr txBox="1"/>
+          <p:nvPr/>
+        </p:nvSpPr>
+        <p:spPr>
+          <a:xfrm>
+            <a:off x="868680" y="566928"/>
+            <a:ext cx="10454640" cy="274320"/>
+          </a:xfrm>
+          <a:prstGeom prst="rect">
+            <a:avLst/>
+          </a:prstGeom>
+          <a:noFill/>
+        </p:spPr>
+        <p:txBody>
+          <a:bodyPr wrap="square" lIns="0" tIns="0" rIns="0" bIns="0" anchor="t">
+            <a:spAutoFit/>
+          </a:bodyPr>
+          <a:lstStyle/>
+          <a:p>
+            <a:r>
+              <a:rPr sz="1250" b="1">
+                <a:solidFill>
+                  <a:srgbClr val="0B57D0"/>
+                </a:solidFill>
+                <a:latin typeface="Arial"/>
+              </a:rPr>
+              <a:t>04 · NAVIGATION</a:t>
+            </a:r>
+          </a:p>
+        </p:txBody>
+      </p:sp>
+      <p:sp>
+        <p:nvSpPr>
+          <p:cNvPr id="3" name="TextBox 2"/>
+          <p:cNvSpPr txBox="1"/>
+          <p:nvPr/>
+        </p:nvSpPr>
+        <p:spPr>
+          <a:xfrm>
+            <a:off x="868680" y="896112"/>
+            <a:ext cx="10454640" cy="658368"/>
+          </a:xfrm>
+          <a:prstGeom prst="rect">
+            <a:avLst/>
+          </a:prstGeom>
+          <a:noFill/>
+        </p:spPr>
+        <p:txBody>
+          <a:bodyPr wrap="square" lIns="0" tIns="0" rIns="0" bIns="0" anchor="t">
+            <a:spAutoFit/>
+          </a:bodyPr>
+          <a:lstStyle/>
+          <a:p>
+            <a:r>
+              <a:rPr sz="2900" b="1">
+                <a:solidFill>
+                  <a:srgbClr val="1A1C1E"/>
+                </a:solidFill>
+                <a:latin typeface="Arial"/>
+              </a:rPr>
+              <a:t>Fußweg-Navigation zum ausgewählten POI</a:t>
+            </a:r>
+          </a:p>
+        </p:txBody>
+      </p:sp>
+      <p:sp>
+        <p:nvSpPr>
+          <p:cNvPr id="4" name="Rectangle 3"/>
+          <p:cNvSpPr/>
+          <p:nvPr/>
+        </p:nvSpPr>
+        <p:spPr>
+          <a:xfrm>
+            <a:off x="868680" y="1572768"/>
+            <a:ext cx="1234440" cy="45720"/>
+          </a:xfrm>
+          <a:prstGeom prst="rect">
+            <a:avLst/>
+          </a:prstGeom>
+          <a:solidFill>
+            <a:srgbClr val="0B57D0"/>
+          </a:solidFill>
+          <a:ln>
+            <a:noFill/>
+          </a:ln>
+          <a:effectLst/>
+        </p:spPr>
+        <p:style>
+          <a:lnRef idx="1">
+            <a:schemeClr val="accent1"/>
+          </a:lnRef>
+          <a:fillRef idx="3">
+            <a:schemeClr val="accent1"/>
+          </a:fillRef>
+          <a:effectRef idx="2">
+            <a:schemeClr val="accent1"/>
+          </a:effectRef>
+          <a:fontRef idx="minor">
+            <a:schemeClr val="lt1"/>
+          </a:fontRef>
+        </p:style>
+        <p:txBody>
+          <a:bodyPr rtlCol="0" anchor="ctr"/>
+          <a:lstStyle/>
+          <a:p>
+            <a:pPr algn="ctr"/>
+            <a:endParaRPr/>
+          </a:p>
+        </p:txBody>
+      </p:sp>
+      <p:sp>
+        <p:nvSpPr>
+          <p:cNvPr id="5" name="TextBox 4"/>
+          <p:cNvSpPr txBox="1"/>
+          <p:nvPr/>
+        </p:nvSpPr>
+        <p:spPr>
+          <a:xfrm>
+            <a:off x="868680" y="1975104"/>
+            <a:ext cx="10454640" cy="2301143"/>
+          </a:xfrm>
+          <a:prstGeom prst="rect">
+            <a:avLst/>
+          </a:prstGeom>
+          <a:noFill/>
+        </p:spPr>
+        <p:txBody>
+          <a:bodyPr wrap="square" lIns="0" tIns="0" rIns="0" bIns="0" anchor="t">
+            <a:spAutoFit/>
+          </a:bodyPr>
+          <a:lstStyle/>
+          <a:p>
+            <a:pPr marL="274320" indent="-274320">
+              <a:lnSpc>
+                <a:spcPct val="150000"/>
+              </a:lnSpc>
+              <a:spcAft>
+                <a:spcPts val="1300"/>
+              </a:spcAft>
+              <a:buNone/>
+            </a:pPr>
+            <a:r>
+              <a:rPr sz="1600" b="1" dirty="0">
+                <a:solidFill>
+                  <a:srgbClr val="0B57D0"/>
+                </a:solidFill>
+                <a:latin typeface="Arial"/>
+              </a:rPr>
+              <a:t>▪  </a:t>
+            </a:r>
+            <a:r>
+              <a:rPr sz="1600" b="1" dirty="0">
+                <a:solidFill>
+                  <a:srgbClr val="1A1C1E"/>
+                </a:solidFill>
+                <a:latin typeface="Arial"/>
+              </a:rPr>
+              <a:t>Route auf </a:t>
+            </a:r>
+            <a:r>
+              <a:rPr sz="1600" b="1" dirty="0" err="1">
+                <a:solidFill>
+                  <a:srgbClr val="1A1C1E"/>
+                </a:solidFill>
+                <a:latin typeface="Arial"/>
+              </a:rPr>
+              <a:t>Knopfdruck</a:t>
+            </a:r>
+            <a:r>
+              <a:rPr sz="1600" b="1" dirty="0">
+                <a:solidFill>
+                  <a:srgbClr val="1A1C1E"/>
+                </a:solidFill>
+                <a:latin typeface="Arial"/>
+              </a:rPr>
+              <a:t>:  </a:t>
+            </a:r>
+            <a:r>
+              <a:rPr sz="1600" b="0" dirty="0">
+                <a:solidFill>
+                  <a:srgbClr val="5F6368"/>
+                </a:solidFill>
+                <a:latin typeface="Arial"/>
+              </a:rPr>
+              <a:t>der Button </a:t>
+            </a:r>
+            <a:r>
+              <a:rPr sz="1600" b="0" dirty="0" err="1">
+                <a:solidFill>
+                  <a:srgbClr val="5F6368"/>
+                </a:solidFill>
+                <a:latin typeface="Arial"/>
+              </a:rPr>
+              <a:t>über</a:t>
+            </a:r>
+            <a:r>
+              <a:rPr sz="1600" b="0" dirty="0">
+                <a:solidFill>
+                  <a:srgbClr val="5F6368"/>
+                </a:solidFill>
+                <a:latin typeface="Arial"/>
+              </a:rPr>
+              <a:t> dem Sheet </a:t>
+            </a:r>
+            <a:r>
+              <a:rPr sz="1600" b="0" dirty="0" err="1">
+                <a:solidFill>
+                  <a:srgbClr val="5F6368"/>
+                </a:solidFill>
+                <a:latin typeface="Arial"/>
+              </a:rPr>
+              <a:t>berechnet</a:t>
+            </a:r>
+            <a:r>
+              <a:rPr sz="1600" b="0" dirty="0">
+                <a:solidFill>
+                  <a:srgbClr val="5F6368"/>
+                </a:solidFill>
+                <a:latin typeface="Arial"/>
+              </a:rPr>
+              <a:t> den Weg </a:t>
+            </a:r>
+            <a:r>
+              <a:rPr sz="1600" b="0" dirty="0" err="1">
+                <a:solidFill>
+                  <a:srgbClr val="5F6368"/>
+                </a:solidFill>
+                <a:latin typeface="Arial"/>
+              </a:rPr>
+              <a:t>vom</a:t>
+            </a:r>
+            <a:r>
+              <a:rPr sz="1600" b="0" dirty="0">
+                <a:solidFill>
+                  <a:srgbClr val="5F6368"/>
+                </a:solidFill>
+                <a:latin typeface="Arial"/>
+              </a:rPr>
+              <a:t> </a:t>
+            </a:r>
+            <a:r>
+              <a:rPr sz="1600" b="0" dirty="0" err="1">
+                <a:solidFill>
+                  <a:srgbClr val="5F6368"/>
+                </a:solidFill>
+                <a:latin typeface="Arial"/>
+              </a:rPr>
+              <a:t>aktuellen</a:t>
+            </a:r>
+            <a:r>
+              <a:rPr sz="1600" b="0" dirty="0">
+                <a:solidFill>
+                  <a:srgbClr val="5F6368"/>
+                </a:solidFill>
+                <a:latin typeface="Arial"/>
+              </a:rPr>
+              <a:t> </a:t>
+            </a:r>
+            <a:r>
+              <a:rPr sz="1600" b="0" dirty="0" err="1">
+                <a:solidFill>
+                  <a:srgbClr val="5F6368"/>
+                </a:solidFill>
+                <a:latin typeface="Arial"/>
+              </a:rPr>
+              <a:t>Standort</a:t>
+            </a:r>
+            <a:r>
+              <a:rPr sz="1600" b="0" dirty="0">
+                <a:solidFill>
+                  <a:srgbClr val="5F6368"/>
+                </a:solidFill>
+                <a:latin typeface="Arial"/>
+              </a:rPr>
+              <a:t> </a:t>
+            </a:r>
+            <a:r>
+              <a:rPr sz="1600" b="0" dirty="0" err="1">
+                <a:solidFill>
+                  <a:srgbClr val="5F6368"/>
+                </a:solidFill>
+                <a:latin typeface="Arial"/>
+              </a:rPr>
+              <a:t>zum</a:t>
+            </a:r>
+            <a:r>
+              <a:rPr sz="1600" b="0" dirty="0">
+                <a:solidFill>
+                  <a:srgbClr val="5F6368"/>
+                </a:solidFill>
+                <a:latin typeface="Arial"/>
+              </a:rPr>
+              <a:t> POI</a:t>
+            </a:r>
+          </a:p>
+          <a:p>
+            <a:pPr marL="274320" indent="-274320">
+              <a:lnSpc>
+                <a:spcPct val="150000"/>
+              </a:lnSpc>
+              <a:spcAft>
+                <a:spcPts val="1300"/>
+              </a:spcAft>
+              <a:buNone/>
+            </a:pPr>
+            <a:r>
+              <a:rPr sz="1600" b="1" dirty="0">
+                <a:solidFill>
+                  <a:srgbClr val="0B57D0"/>
+                </a:solidFill>
+                <a:latin typeface="Arial"/>
+              </a:rPr>
+              <a:t>▪  </a:t>
+            </a:r>
+            <a:r>
+              <a:rPr sz="1600" b="1" dirty="0">
+                <a:solidFill>
+                  <a:srgbClr val="1A1C1E"/>
+                </a:solidFill>
+                <a:latin typeface="Arial"/>
+              </a:rPr>
+              <a:t>Graph </a:t>
+            </a:r>
+            <a:r>
+              <a:rPr sz="1600" b="1" dirty="0" err="1">
+                <a:solidFill>
+                  <a:srgbClr val="1A1C1E"/>
+                </a:solidFill>
+                <a:latin typeface="Arial"/>
+              </a:rPr>
+              <a:t>aus</a:t>
+            </a:r>
+            <a:r>
+              <a:rPr sz="1600" b="1" dirty="0">
+                <a:solidFill>
+                  <a:srgbClr val="1A1C1E"/>
+                </a:solidFill>
+                <a:latin typeface="Arial"/>
+              </a:rPr>
+              <a:t> den OSM-Linien:  </a:t>
+            </a:r>
+            <a:r>
+              <a:rPr sz="1600" b="0" dirty="0" err="1">
+                <a:solidFill>
+                  <a:srgbClr val="5F6368"/>
+                </a:solidFill>
+                <a:latin typeface="Arial"/>
+              </a:rPr>
+              <a:t>gemeinsame</a:t>
+            </a:r>
+            <a:r>
+              <a:rPr sz="1600" b="0" dirty="0">
+                <a:solidFill>
+                  <a:srgbClr val="5F6368"/>
+                </a:solidFill>
+                <a:latin typeface="Arial"/>
+              </a:rPr>
+              <a:t> Koordinaten </a:t>
+            </a:r>
+            <a:r>
+              <a:rPr sz="1600" b="0" dirty="0" err="1">
+                <a:solidFill>
+                  <a:srgbClr val="5F6368"/>
+                </a:solidFill>
+                <a:latin typeface="Arial"/>
+              </a:rPr>
+              <a:t>zweier</a:t>
+            </a:r>
+            <a:r>
+              <a:rPr sz="1600" b="0" dirty="0">
+                <a:solidFill>
+                  <a:srgbClr val="5F6368"/>
+                </a:solidFill>
+                <a:latin typeface="Arial"/>
+              </a:rPr>
+              <a:t> Wege </a:t>
+            </a:r>
+            <a:r>
+              <a:rPr sz="1600" b="0" dirty="0" err="1">
+                <a:solidFill>
+                  <a:srgbClr val="5F6368"/>
+                </a:solidFill>
+                <a:latin typeface="Arial"/>
+              </a:rPr>
+              <a:t>ergeben</a:t>
+            </a:r>
+            <a:r>
+              <a:rPr sz="1600" b="0" dirty="0">
+                <a:solidFill>
+                  <a:srgbClr val="5F6368"/>
+                </a:solidFill>
+                <a:latin typeface="Arial"/>
+              </a:rPr>
+              <a:t> </a:t>
+            </a:r>
+            <a:r>
+              <a:rPr sz="1600" b="0" dirty="0" err="1">
+                <a:solidFill>
+                  <a:srgbClr val="5F6368"/>
+                </a:solidFill>
+                <a:latin typeface="Arial"/>
+              </a:rPr>
+              <a:t>eine</a:t>
+            </a:r>
+            <a:r>
+              <a:rPr sz="1600" b="0" dirty="0">
+                <a:solidFill>
+                  <a:srgbClr val="5F6368"/>
+                </a:solidFill>
+                <a:latin typeface="Arial"/>
+              </a:rPr>
+              <a:t> </a:t>
+            </a:r>
+            <a:r>
+              <a:rPr sz="1600" b="0" dirty="0" err="1">
+                <a:solidFill>
+                  <a:srgbClr val="5F6368"/>
+                </a:solidFill>
+                <a:latin typeface="Arial"/>
+              </a:rPr>
+              <a:t>Kreuzung</a:t>
+            </a:r>
+            <a:r>
+              <a:rPr sz="1600" b="0" dirty="0">
+                <a:solidFill>
+                  <a:srgbClr val="5F6368"/>
+                </a:solidFill>
+                <a:latin typeface="Arial"/>
+              </a:rPr>
+              <a:t> – </a:t>
+            </a:r>
+            <a:r>
+              <a:rPr sz="1600" b="0" dirty="0" err="1">
+                <a:solidFill>
+                  <a:srgbClr val="5F6368"/>
+                </a:solidFill>
+                <a:latin typeface="Arial"/>
+              </a:rPr>
+              <a:t>Brücken</a:t>
+            </a:r>
+            <a:r>
+              <a:rPr sz="1600" b="0" dirty="0">
+                <a:solidFill>
+                  <a:srgbClr val="5F6368"/>
+                </a:solidFill>
+                <a:latin typeface="Arial"/>
+              </a:rPr>
+              <a:t> und Tunnel </a:t>
+            </a:r>
+            <a:r>
+              <a:rPr sz="1600" b="0" dirty="0" err="1">
+                <a:solidFill>
+                  <a:srgbClr val="5F6368"/>
+                </a:solidFill>
+                <a:latin typeface="Arial"/>
+              </a:rPr>
+              <a:t>bleiben</a:t>
+            </a:r>
+            <a:r>
+              <a:rPr sz="1600" b="0" dirty="0">
+                <a:solidFill>
+                  <a:srgbClr val="5F6368"/>
+                </a:solidFill>
+                <a:latin typeface="Arial"/>
+              </a:rPr>
+              <a:t> </a:t>
+            </a:r>
+            <a:r>
+              <a:rPr sz="1600" b="0" dirty="0" err="1">
+                <a:solidFill>
+                  <a:srgbClr val="5F6368"/>
+                </a:solidFill>
+                <a:latin typeface="Arial"/>
+              </a:rPr>
+              <a:t>dabei</a:t>
+            </a:r>
+            <a:r>
+              <a:rPr sz="1600" b="0" dirty="0">
+                <a:solidFill>
+                  <a:srgbClr val="5F6368"/>
+                </a:solidFill>
+                <a:latin typeface="Arial"/>
+              </a:rPr>
+              <a:t> </a:t>
+            </a:r>
+            <a:r>
+              <a:rPr sz="1600" b="0" dirty="0" err="1">
+                <a:solidFill>
+                  <a:srgbClr val="5F6368"/>
+                </a:solidFill>
+                <a:latin typeface="Arial"/>
+              </a:rPr>
+              <a:t>korrekt</a:t>
+            </a:r>
+            <a:r>
+              <a:rPr sz="1600" b="0" dirty="0">
+                <a:solidFill>
+                  <a:srgbClr val="5F6368"/>
+                </a:solidFill>
+                <a:latin typeface="Arial"/>
+              </a:rPr>
+              <a:t> </a:t>
+            </a:r>
+            <a:r>
+              <a:rPr sz="1600" b="0" dirty="0" err="1">
+                <a:solidFill>
+                  <a:srgbClr val="5F6368"/>
+                </a:solidFill>
+                <a:latin typeface="Arial"/>
+              </a:rPr>
+              <a:t>getrennt</a:t>
+            </a:r>
+            <a:endParaRPr sz="1600" b="0" dirty="0">
+              <a:solidFill>
+                <a:srgbClr val="5F6368"/>
+              </a:solidFill>
+              <a:latin typeface="Arial"/>
+            </a:endParaRPr>
+          </a:p>
+          <a:p>
+            <a:pPr marL="274320" indent="-274320">
+              <a:lnSpc>
+                <a:spcPct val="150000"/>
+              </a:lnSpc>
+              <a:spcAft>
+                <a:spcPts val="1300"/>
+              </a:spcAft>
+              <a:buNone/>
+            </a:pPr>
+            <a:r>
+              <a:rPr sz="1600" b="1" dirty="0">
+                <a:solidFill>
+                  <a:srgbClr val="0B57D0"/>
+                </a:solidFill>
+                <a:latin typeface="Arial"/>
+              </a:rPr>
+              <a:t>▪  </a:t>
+            </a:r>
+            <a:r>
+              <a:rPr sz="1600" b="1" dirty="0">
+                <a:solidFill>
+                  <a:srgbClr val="1A1C1E"/>
+                </a:solidFill>
+                <a:latin typeface="Arial"/>
+              </a:rPr>
+              <a:t>A* </a:t>
+            </a:r>
+            <a:r>
+              <a:rPr sz="1600" b="1" dirty="0" err="1">
+                <a:solidFill>
+                  <a:srgbClr val="1A1C1E"/>
+                </a:solidFill>
+                <a:latin typeface="Arial"/>
+              </a:rPr>
+              <a:t>mit</a:t>
+            </a:r>
+            <a:r>
+              <a:rPr sz="1600" b="1" dirty="0">
+                <a:solidFill>
+                  <a:srgbClr val="1A1C1E"/>
+                </a:solidFill>
+                <a:latin typeface="Arial"/>
+              </a:rPr>
+              <a:t> </a:t>
+            </a:r>
+            <a:r>
+              <a:rPr sz="1600" b="1" dirty="0" err="1">
+                <a:solidFill>
+                  <a:srgbClr val="1A1C1E"/>
+                </a:solidFill>
+                <a:latin typeface="Arial"/>
+              </a:rPr>
+              <a:t>Luftlinien-Heuristik</a:t>
+            </a:r>
+            <a:r>
+              <a:rPr sz="1600" b="1" dirty="0">
+                <a:solidFill>
+                  <a:srgbClr val="1A1C1E"/>
+                </a:solidFill>
+                <a:latin typeface="Arial"/>
+              </a:rPr>
+              <a:t>:  </a:t>
+            </a:r>
+            <a:r>
+              <a:rPr sz="1600" b="0" dirty="0" err="1">
+                <a:solidFill>
+                  <a:srgbClr val="5F6368"/>
+                </a:solidFill>
+                <a:latin typeface="Arial"/>
+              </a:rPr>
+              <a:t>findet</a:t>
+            </a:r>
+            <a:r>
+              <a:rPr sz="1600" b="0" dirty="0">
+                <a:solidFill>
+                  <a:srgbClr val="5F6368"/>
+                </a:solidFill>
+                <a:latin typeface="Arial"/>
+              </a:rPr>
+              <a:t> </a:t>
+            </a:r>
+            <a:r>
+              <a:rPr sz="1600" b="0" dirty="0" err="1">
+                <a:solidFill>
+                  <a:srgbClr val="5F6368"/>
+                </a:solidFill>
+                <a:latin typeface="Arial"/>
+              </a:rPr>
+              <a:t>garantiert</a:t>
+            </a:r>
+            <a:r>
+              <a:rPr sz="1600" b="0" dirty="0">
+                <a:solidFill>
+                  <a:srgbClr val="5F6368"/>
+                </a:solidFill>
+                <a:latin typeface="Arial"/>
+              </a:rPr>
+              <a:t> den </a:t>
+            </a:r>
+            <a:r>
+              <a:rPr sz="1600" b="0" dirty="0" err="1">
+                <a:solidFill>
+                  <a:srgbClr val="5F6368"/>
+                </a:solidFill>
+                <a:latin typeface="Arial"/>
+              </a:rPr>
+              <a:t>kürzesten</a:t>
+            </a:r>
+            <a:r>
+              <a:rPr sz="1600" b="0" dirty="0">
+                <a:solidFill>
+                  <a:srgbClr val="5F6368"/>
+                </a:solidFill>
+                <a:latin typeface="Arial"/>
+              </a:rPr>
+              <a:t> Weg, </a:t>
+            </a:r>
+            <a:r>
+              <a:rPr sz="1600" b="0" dirty="0" err="1">
+                <a:solidFill>
+                  <a:srgbClr val="5F6368"/>
+                </a:solidFill>
+                <a:latin typeface="Arial"/>
+              </a:rPr>
+              <a:t>prüft</a:t>
+            </a:r>
+            <a:r>
+              <a:rPr sz="1600" b="0" dirty="0">
+                <a:solidFill>
+                  <a:srgbClr val="5F6368"/>
+                </a:solidFill>
+                <a:latin typeface="Arial"/>
+              </a:rPr>
+              <a:t> </a:t>
+            </a:r>
+            <a:r>
+              <a:rPr sz="1600" b="0" dirty="0" err="1">
+                <a:solidFill>
+                  <a:srgbClr val="5F6368"/>
+                </a:solidFill>
+                <a:latin typeface="Arial"/>
+              </a:rPr>
+              <a:t>aber</a:t>
+            </a:r>
+            <a:r>
+              <a:rPr sz="1600" b="0" dirty="0">
+                <a:solidFill>
+                  <a:srgbClr val="5F6368"/>
+                </a:solidFill>
+                <a:latin typeface="Arial"/>
+              </a:rPr>
+              <a:t> </a:t>
+            </a:r>
+            <a:r>
+              <a:rPr sz="1600" b="0" dirty="0" err="1">
+                <a:solidFill>
+                  <a:srgbClr val="5F6368"/>
+                </a:solidFill>
+                <a:latin typeface="Arial"/>
+              </a:rPr>
+              <a:t>nur</a:t>
+            </a:r>
+            <a:r>
+              <a:rPr sz="1600" b="0" dirty="0">
+                <a:solidFill>
+                  <a:srgbClr val="5F6368"/>
+                </a:solidFill>
+                <a:latin typeface="Arial"/>
+              </a:rPr>
+              <a:t> </a:t>
+            </a:r>
+            <a:r>
+              <a:rPr sz="1600" b="0" dirty="0" err="1">
+                <a:solidFill>
+                  <a:srgbClr val="5F6368"/>
+                </a:solidFill>
+                <a:latin typeface="Arial"/>
+              </a:rPr>
+              <a:t>einen</a:t>
+            </a:r>
+            <a:r>
+              <a:rPr sz="1600" b="0" dirty="0">
+                <a:solidFill>
+                  <a:srgbClr val="5F6368"/>
+                </a:solidFill>
+                <a:latin typeface="Arial"/>
+              </a:rPr>
+              <a:t> </a:t>
+            </a:r>
+            <a:r>
+              <a:rPr sz="1600" b="0" dirty="0" err="1">
+                <a:solidFill>
+                  <a:srgbClr val="5F6368"/>
+                </a:solidFill>
+                <a:latin typeface="Arial"/>
+              </a:rPr>
+              <a:t>Bruchteil</a:t>
+            </a:r>
+            <a:r>
+              <a:rPr sz="1600" b="0" dirty="0">
+                <a:solidFill>
+                  <a:srgbClr val="5F6368"/>
+                </a:solidFill>
+                <a:latin typeface="Arial"/>
+              </a:rPr>
+              <a:t> der Knoten</a:t>
+            </a:r>
+          </a:p>
+          <a:p>
+            <a:pPr marL="274320" indent="-274320">
+              <a:lnSpc>
+                <a:spcPct val="150000"/>
+              </a:lnSpc>
+              <a:spcAft>
+                <a:spcPts val="1300"/>
+              </a:spcAft>
+              <a:buNone/>
+            </a:pPr>
+            <a:r>
+              <a:rPr sz="1600" b="1" dirty="0">
+                <a:solidFill>
+                  <a:srgbClr val="0B57D0"/>
+                </a:solidFill>
+                <a:latin typeface="Arial"/>
+              </a:rPr>
+              <a:t>▪  </a:t>
+            </a:r>
+            <a:r>
+              <a:rPr sz="1600" b="1" dirty="0" err="1">
+                <a:solidFill>
+                  <a:srgbClr val="1A1C1E"/>
+                </a:solidFill>
+                <a:latin typeface="Arial"/>
+              </a:rPr>
+              <a:t>Echte</a:t>
+            </a:r>
+            <a:r>
+              <a:rPr sz="1600" b="1" dirty="0">
+                <a:solidFill>
+                  <a:srgbClr val="1A1C1E"/>
+                </a:solidFill>
+                <a:latin typeface="Arial"/>
+              </a:rPr>
+              <a:t> Bodenmeter:  </a:t>
+            </a:r>
+            <a:r>
+              <a:rPr sz="1600" b="0" dirty="0">
+                <a:solidFill>
+                  <a:srgbClr val="5F6368"/>
+                </a:solidFill>
+                <a:latin typeface="Arial"/>
+              </a:rPr>
+              <a:t>die Mercator-</a:t>
+            </a:r>
+            <a:r>
+              <a:rPr sz="1600" b="0" dirty="0" err="1">
+                <a:solidFill>
+                  <a:srgbClr val="5F6368"/>
+                </a:solidFill>
+                <a:latin typeface="Arial"/>
+              </a:rPr>
+              <a:t>Verzerrung</a:t>
+            </a:r>
+            <a:r>
+              <a:rPr sz="1600" b="0" dirty="0">
+                <a:solidFill>
+                  <a:srgbClr val="5F6368"/>
+                </a:solidFill>
+                <a:latin typeface="Arial"/>
+              </a:rPr>
+              <a:t> </a:t>
+            </a:r>
+            <a:r>
+              <a:rPr sz="1600" b="0" dirty="0" err="1">
+                <a:solidFill>
+                  <a:srgbClr val="5F6368"/>
+                </a:solidFill>
+                <a:latin typeface="Arial"/>
+              </a:rPr>
+              <a:t>wird</a:t>
+            </a:r>
+            <a:r>
+              <a:rPr sz="1600" b="0" dirty="0">
+                <a:solidFill>
+                  <a:srgbClr val="5F6368"/>
+                </a:solidFill>
+                <a:latin typeface="Arial"/>
+              </a:rPr>
+              <a:t> </a:t>
+            </a:r>
+            <a:r>
+              <a:rPr sz="1600" b="0" dirty="0" err="1">
+                <a:solidFill>
+                  <a:srgbClr val="5F6368"/>
+                </a:solidFill>
+                <a:latin typeface="Arial"/>
+              </a:rPr>
+              <a:t>herausgerechnet</a:t>
+            </a:r>
+            <a:r>
+              <a:rPr sz="1600" b="0" dirty="0">
+                <a:solidFill>
+                  <a:srgbClr val="5F6368"/>
+                </a:solidFill>
+                <a:latin typeface="Arial"/>
+              </a:rPr>
+              <a:t>, </a:t>
+            </a:r>
+            <a:r>
+              <a:rPr sz="1600" b="0" dirty="0" err="1">
+                <a:solidFill>
+                  <a:srgbClr val="5F6368"/>
+                </a:solidFill>
+                <a:latin typeface="Arial"/>
+              </a:rPr>
+              <a:t>daher</a:t>
+            </a:r>
+            <a:r>
+              <a:rPr sz="1600" b="0" dirty="0">
+                <a:solidFill>
+                  <a:srgbClr val="5F6368"/>
+                </a:solidFill>
+                <a:latin typeface="Arial"/>
+              </a:rPr>
+              <a:t> </a:t>
+            </a:r>
+            <a:r>
+              <a:rPr sz="1600" b="0" dirty="0" err="1">
+                <a:solidFill>
+                  <a:srgbClr val="5F6368"/>
+                </a:solidFill>
+                <a:latin typeface="Arial"/>
+              </a:rPr>
+              <a:t>stimmen</a:t>
+            </a:r>
+            <a:r>
+              <a:rPr sz="1600" b="0" dirty="0">
+                <a:solidFill>
+                  <a:srgbClr val="5F6368"/>
+                </a:solidFill>
+                <a:latin typeface="Arial"/>
+              </a:rPr>
+              <a:t> </a:t>
+            </a:r>
+            <a:r>
+              <a:rPr sz="1600" b="0" dirty="0" err="1">
+                <a:solidFill>
+                  <a:srgbClr val="5F6368"/>
+                </a:solidFill>
+                <a:latin typeface="Arial"/>
+              </a:rPr>
+              <a:t>Distanz</a:t>
+            </a:r>
+            <a:r>
+              <a:rPr sz="1600" b="0" dirty="0">
+                <a:solidFill>
+                  <a:srgbClr val="5F6368"/>
+                </a:solidFill>
+                <a:latin typeface="Arial"/>
+              </a:rPr>
+              <a:t> und </a:t>
+            </a:r>
+            <a:r>
+              <a:rPr sz="1600" b="0" dirty="0" err="1">
+                <a:solidFill>
+                  <a:srgbClr val="5F6368"/>
+                </a:solidFill>
+                <a:latin typeface="Arial"/>
+              </a:rPr>
+              <a:t>Gehzeit</a:t>
+            </a:r>
+            <a:endParaRPr sz="1600" b="0" dirty="0">
+              <a:solidFill>
+                <a:srgbClr val="5F6368"/>
+              </a:solidFill>
+              <a:latin typeface="Arial"/>
+            </a:endParaRPr>
+          </a:p>
+        </p:txBody>
+      </p:sp>
+      <p:sp>
+        <p:nvSpPr>
+          <p:cNvPr id="14" name="TextBox 13"/>
+          <p:cNvSpPr txBox="1"/>
+          <p:nvPr/>
+        </p:nvSpPr>
+        <p:spPr>
+          <a:xfrm>
+            <a:off x="868680" y="6236208"/>
+            <a:ext cx="10454640" cy="274320"/>
+          </a:xfrm>
+          <a:prstGeom prst="rect">
+            <a:avLst/>
+          </a:prstGeom>
+          <a:noFill/>
+        </p:spPr>
+        <p:txBody>
+          <a:bodyPr wrap="square" lIns="0" tIns="0" rIns="0" bIns="0" anchor="t">
+            <a:spAutoFit/>
+          </a:bodyPr>
+          <a:lstStyle/>
+          <a:p>
+            <a:r>
+              <a:rPr sz="1050" b="0">
+                <a:solidFill>
+                  <a:srgbClr val="8E9099"/>
+                </a:solidFill>
+                <a:latin typeface="Arial"/>
+              </a:rPr>
+              <a:t>CAS-Projekt · Erweiterungen</a:t>
+            </a:r>
+          </a:p>
+        </p:txBody>
+      </p:sp>
+      <p:sp>
+        <p:nvSpPr>
+          <p:cNvPr id="15" name="TextBox 14"/>
+          <p:cNvSpPr txBox="1"/>
+          <p:nvPr/>
+        </p:nvSpPr>
+        <p:spPr>
+          <a:xfrm>
+            <a:off x="868680" y="6236208"/>
+            <a:ext cx="10454640" cy="274320"/>
+          </a:xfrm>
+          <a:prstGeom prst="rect">
+            <a:avLst/>
+          </a:prstGeom>
+          <a:noFill/>
+        </p:spPr>
+        <p:txBody>
+          <a:bodyPr wrap="square" lIns="0" tIns="0" rIns="0" bIns="0" anchor="t">
+            <a:spAutoFit/>
+          </a:bodyPr>
+          <a:lstStyle/>
+          <a:p>
+            <a:pPr algn="r"/>
+            <a:r>
+              <a:rPr sz="1050" b="0">
+                <a:solidFill>
+                  <a:srgbClr val="8E9099"/>
+                </a:solidFill>
+                <a:latin typeface="Arial"/>
+              </a:rPr>
+              <a:t>5</a:t>
+            </a:r>
+          </a:p>
+        </p:txBody>
+      </p:sp>
+    </p:spTree>
+  </p:cSld>
+  <p:clrMapOvr>
+    <a:masterClrMapping/>
+  </p:clrMapOvr>
+</p:sld>
+</file>
+
+<file path=ppt/slides/slide6.xml><?xml version="1.0" encoding="utf-8"?>
 <p:sld xmlns:a="http://schemas.openxmlformats.org/drawingml/2006/main" xmlns:r="http://schemas.openxmlformats.org/officeDocument/2006/relationships" xmlns:p="http://schemas.openxmlformats.org/presentationml/2006/main">
   <p:cSld>
     <p:spTree>

</xml_diff>